<commit_message>
Restyle les diapositives risques financiers au style du dossier LMT
Co-Authored-By: Claude Opus 5.5 <noreply@anthropic.com>
Claude-Session: https://claude.ai/code/session_01KosXhrXQ9qsTuEHYPMpBd7
</commit_message>
<xml_diff>
--- a/Partie8_Inde_Risques.pptx
+++ b/Partie8_Inde_Risques.pptx
@@ -108,7 +108,7 @@
   <p:extLst>
     <p:ext uri="{521415D9-36F7-43E2-AB2F-B90AF26B5E84}">
       <p14:sectionLst xmlns:p14="http://schemas.microsoft.com/office/powerpoint/2010/main">
-        <p14:section name="Partie 8" id="{63d765a4-560b-e99f-c4cc-ec92127142b0}">
+        <p14:section name="Risques financiers, humains et réputationnels" id="{fab45ce1-89db-8c6c-3b97-40cc333c2e54}">
           <p14:sldIdLst>
             <p14:sldId id="256"/>
             <p14:sldId id="257"/>
@@ -518,7 +518,7 @@
           <a:p>
             <a:r>
               <a:rPr lang="en-US" dirty="0"/>
-              <a:t>Make in India : l'Inde impose de produire localement, donc LMT doit trouver un partenaire indien et assembler sur place. L'accord de libre-échange UE-Inde n'est pas encore en vigueur (espéré pour 2027), donc les conditions commerciales actuelles restent plus contraignantes.</a:t>
+              <a:t>Make in India : l'Inde impose de produire localement, donc LMT doit trouver un partenaire indien et assembler sur place. L'accord UE-Inde n'est pas encore en vigueur (espéré pour 2027), donc les conditions commerciales actuelles restent plus contraignantes.</a:t>
             </a:r>
             <a:endParaRPr lang="en-US" dirty="0"/>
           </a:p>
@@ -680,156 +680,7 @@
 
 <file path=ppt/slideLayouts/slideLayout2.xml><?xml version="1.0" encoding="utf-8"?>
 <p:sldLayout xmlns:a="http://schemas.openxmlformats.org/drawingml/2006/main" xmlns:r="http://schemas.openxmlformats.org/officeDocument/2006/relationships" xmlns:p="http://schemas.openxmlformats.org/presentationml/2006/main" preserve="1">
-  <p:cSld name="Titre">
-    <p:bg>
-      <p:bgPr>
-        <a:solidFill>
-          <a:schemeClr val="tx1"/>
-        </a:solidFill>
-      </p:bgPr>
-    </p:bg>
-    <p:spTree>
-      <p:nvGrpSpPr>
-        <p:cNvPr id="1" name=""/>
-        <p:cNvGrpSpPr/>
-        <p:nvPr/>
-      </p:nvGrpSpPr>
-      <p:grpSpPr>
-        <a:xfrm>
-          <a:off x="0" y="0"/>
-          <a:ext cx="0" cy="0"/>
-          <a:chOff x="0" y="0"/>
-          <a:chExt cx="0" cy="0"/>
-        </a:xfrm>
-      </p:grpSpPr>
-      <p:sp>
-        <p:nvSpPr>
-          <p:cNvPr id="2" name="Text 0"/>
-          <p:cNvSpPr/>
-          <p:nvPr>
-            <p:ph idx="100" type="body" hasCustomPrompt="1"/>
-          </p:nvPr>
-        </p:nvSpPr>
-        <p:spPr>
-          <a:xfrm>
-            <a:off x="548640" y="822960"/>
-            <a:ext cx="8046720" cy="365760"/>
-          </a:xfrm>
-          <a:prstGeom prst="rect">
-            <a:avLst/>
-          </a:prstGeom>
-          <a:noFill/>
-          <a:ln/>
-        </p:spPr>
-        <p:txBody>
-          <a:bodyPr wrap="square" rtlCol="0"/>
-          <a:lstStyle>
-            <a:lvl1pPr indent="0" marL="0">
-              <a:buNone/>
-              <a:defRPr lang="en-US" sz="1600" b="1" spc="200" kern="0" dirty="0">
-                <a:solidFill>
-                  <a:srgbClr val="E9B27A"/>
-                </a:solidFill>
-              </a:defRPr>
-            </a:lvl1pPr>
-          </a:lstStyle>
-          <a:p>
-            <a:pPr indent="0" marL="0">
-              <a:buNone/>
-            </a:pPr>
-            <a:endParaRPr lang="en-US" sz="1600" dirty="0"/>
-          </a:p>
-        </p:txBody>
-      </p:sp>
-      <p:sp>
-        <p:nvSpPr>
-          <p:cNvPr id="3" name="Text 0"/>
-          <p:cNvSpPr/>
-          <p:nvPr>
-            <p:ph idx="101" type="title" hasCustomPrompt="1"/>
-          </p:nvPr>
-        </p:nvSpPr>
-        <p:spPr>
-          <a:xfrm>
-            <a:off x="548640" y="1234440"/>
-            <a:ext cx="8046720" cy="1371600"/>
-          </a:xfrm>
-          <a:prstGeom prst="rect">
-            <a:avLst/>
-          </a:prstGeom>
-          <a:noFill/>
-          <a:ln/>
-        </p:spPr>
-        <p:txBody>
-          <a:bodyPr wrap="square" rtlCol="0"/>
-          <a:lstStyle>
-            <a:lvl1pPr algn="l" indent="0" marL="0">
-              <a:buNone/>
-              <a:defRPr lang="en-US" sz="3800" b="1" dirty="0">
-                <a:solidFill>
-                  <a:schemeClr val="bg1"/>
-                </a:solidFill>
-              </a:defRPr>
-            </a:lvl1pPr>
-          </a:lstStyle>
-          <a:p>
-            <a:pPr algn="l" indent="0" marL="0">
-              <a:buNone/>
-            </a:pPr>
-            <a:endParaRPr lang="en-US" sz="3800" dirty="0"/>
-          </a:p>
-        </p:txBody>
-      </p:sp>
-      <p:sp>
-        <p:nvSpPr>
-          <p:cNvPr id="4" name="Text 0"/>
-          <p:cNvSpPr/>
-          <p:nvPr>
-            <p:ph idx="102" type="body" hasCustomPrompt="1"/>
-          </p:nvPr>
-        </p:nvSpPr>
-        <p:spPr>
-          <a:xfrm>
-            <a:off x="548640" y="2697480"/>
-            <a:ext cx="8046720" cy="457200"/>
-          </a:xfrm>
-          <a:prstGeom prst="rect">
-            <a:avLst/>
-          </a:prstGeom>
-          <a:noFill/>
-          <a:ln/>
-        </p:spPr>
-        <p:txBody>
-          <a:bodyPr wrap="square" rtlCol="0"/>
-          <a:lstStyle>
-            <a:lvl1pPr indent="0" marL="0">
-              <a:buNone/>
-              <a:defRPr lang="en-US" sz="1800" dirty="0">
-                <a:solidFill>
-                  <a:srgbClr val="C9D1DB"/>
-                </a:solidFill>
-              </a:defRPr>
-            </a:lvl1pPr>
-          </a:lstStyle>
-          <a:p>
-            <a:pPr indent="0" marL="0">
-              <a:buNone/>
-            </a:pPr>
-            <a:endParaRPr lang="en-US" sz="1800" dirty="0"/>
-          </a:p>
-        </p:txBody>
-      </p:sp>
-    </p:spTree>
-  </p:cSld>
-  <p:clrMapOvr>
-    <a:masterClrMapping/>
-  </p:clrMapOvr>
-</p:sldLayout>
-</file>
-
-<file path=ppt/slideLayouts/slideLayout3.xml><?xml version="1.0" encoding="utf-8"?>
-<p:sldLayout xmlns:a="http://schemas.openxmlformats.org/drawingml/2006/main" xmlns:r="http://schemas.openxmlformats.org/officeDocument/2006/relationships" xmlns:p="http://schemas.openxmlformats.org/presentationml/2006/main" preserve="1">
-  <p:cSld name="Contenu">
+  <p:cSld name="Bandeau">
     <p:bg>
       <p:bgPr>
         <a:solidFill>
@@ -853,16 +704,41 @@
       </p:grpSpPr>
       <p:sp>
         <p:nvSpPr>
-          <p:cNvPr id="2" name="Text 0"/>
+          <p:cNvPr id="2" name="Shape 0"/>
+          <p:cNvSpPr/>
+          <p:nvPr/>
+        </p:nvSpPr>
+        <p:spPr>
+          <a:xfrm>
+            <a:off x="0" y="0"/>
+            <a:ext cx="9144000" cy="786384"/>
+          </a:xfrm>
+          <a:prstGeom prst="rect">
+            <a:avLst/>
+          </a:prstGeom>
+          <a:solidFill>
+            <a:schemeClr val="tx1"/>
+          </a:solidFill>
+          <a:ln w="12700">
+            <a:solidFill>
+              <a:schemeClr val="tx1"/>
+            </a:solidFill>
+            <a:prstDash val="solid"/>
+          </a:ln>
+        </p:spPr>
+      </p:sp>
+      <p:sp>
+        <p:nvSpPr>
+          <p:cNvPr id="3" name="Text 1"/>
           <p:cNvSpPr/>
           <p:nvPr>
-            <p:ph idx="100" type="title" hasCustomPrompt="1"/>
+            <p:ph idx="101" type="title" hasCustomPrompt="1"/>
           </p:nvPr>
         </p:nvSpPr>
         <p:spPr>
           <a:xfrm>
-            <a:off x="457200" y="274320"/>
-            <a:ext cx="8229600" cy="685800"/>
+            <a:off x="411480" y="0"/>
+            <a:ext cx="8321040" cy="786384"/>
           </a:xfrm>
           <a:prstGeom prst="rect">
             <a:avLst/>
@@ -873,220 +749,59 @@
         <p:txBody>
           <a:bodyPr wrap="square" rtlCol="0"/>
           <a:lstStyle>
-            <a:lvl1pPr indent="0" marL="0">
-              <a:buNone/>
-              <a:defRPr lang="en-US" sz="3000" b="1" dirty="0">
+            <a:lvl1pPr algn="l" indent="0" marL="0">
+              <a:buNone/>
+              <a:defRPr lang="en-US" sz="2600" b="1" dirty="0">
                 <a:solidFill>
-                  <a:schemeClr val="tx1"/>
+                  <a:schemeClr val="bg1"/>
                 </a:solidFill>
               </a:defRPr>
             </a:lvl1pPr>
           </a:lstStyle>
           <a:p>
-            <a:pPr indent="0" marL="0">
+            <a:pPr algn="l" indent="0" marL="0">
               <a:buNone/>
             </a:pPr>
-            <a:endParaRPr lang="en-US" sz="3000" dirty="0"/>
-          </a:p>
-        </p:txBody>
-      </p:sp>
-      <p:sp>
-        <p:nvSpPr>
-          <p:cNvPr id="25" name="Slide Number Placeholder 0"/>
-          <p:cNvSpPr>
-            <a:spLocks noGrp="1"/>
-          </p:cNvSpPr>
+            <a:endParaRPr lang="en-US" sz="2600" dirty="0"/>
+          </a:p>
+        </p:txBody>
+      </p:sp>
+      <p:sp>
+        <p:nvSpPr>
+          <p:cNvPr id="4" name="Text 1"/>
+          <p:cNvSpPr/>
           <p:nvPr>
-            <p:ph type="sldNum" sz="quarter" idx="4294967295"/>
+            <p:ph idx="102" type="body" hasCustomPrompt="1"/>
           </p:nvPr>
         </p:nvSpPr>
         <p:spPr>
           <a:xfrm>
-            <a:off x="8412480" y="4754880"/>
-            <a:ext cx="457200" cy="274320"/>
-          </a:xfrm>
-          <a:prstGeom prst="rect">
-            <a:avLst/>
-          </a:prstGeom>
-          <a:extLst>
-            <a:ext uri="{C572A759-6A51-4108-AA02-DFA0A04FC94B}">
-              <ma14:wrappingTextBoxFlag xmlns:ma14="http://schemas.microsoft.com/office/mac/drawingml/2011/main" val="0"/>
-            </a:ext>
-          </a:extLst>
-        </p:spPr>
-        <p:txBody>
-          <a:bodyPr/>
+            <a:off x="411480" y="914400"/>
+            <a:ext cx="8321040" cy="411480"/>
+          </a:xfrm>
+          <a:prstGeom prst="rect">
+            <a:avLst/>
+          </a:prstGeom>
+          <a:noFill/>
+          <a:ln/>
+        </p:spPr>
+        <p:txBody>
+          <a:bodyPr wrap="square" rtlCol="0"/>
           <a:lstStyle>
-            <a:lvl1pPr>
-              <a:defRPr sz="1000">
+            <a:lvl1pPr algn="l" indent="0" marL="0">
+              <a:buNone/>
+              <a:defRPr lang="en-US" sz="1800" b="1" dirty="0">
                 <a:solidFill>
-                  <a:schemeClr val="accent4"/>
+                  <a:schemeClr val="accent1"/>
                 </a:solidFill>
               </a:defRPr>
             </a:lvl1pPr>
           </a:lstStyle>
           <a:p>
-            <a:pPr algn="r"/>
-            <a:fld id="{F7021451-1387-4CA6-816F-3879F97B5CBC}" type="slidenum">
-              <a:rPr b="0" lang="en-US"/>
-              <a:t>1003</a:t>
-            </a:fld>
-            <a:endParaRPr lang="en-US"/>
-          </a:p>
-        </p:txBody>
-      </p:sp>
-    </p:spTree>
-  </p:cSld>
-  <p:clrMapOvr>
-    <a:masterClrMapping/>
-  </p:clrMapOvr>
-</p:sldLayout>
-</file>
-
-<file path=ppt/slideLayouts/slideLayout4.xml><?xml version="1.0" encoding="utf-8"?>
-<p:sldLayout xmlns:a="http://schemas.openxmlformats.org/drawingml/2006/main" xmlns:r="http://schemas.openxmlformats.org/officeDocument/2006/relationships" xmlns:p="http://schemas.openxmlformats.org/presentationml/2006/main" preserve="1">
-  <p:cSld name="Section8">
-    <p:bg>
-      <p:bgPr>
-        <a:solidFill>
-          <a:schemeClr val="bg1"/>
-        </a:solidFill>
-      </p:bgPr>
-    </p:bg>
-    <p:spTree>
-      <p:nvGrpSpPr>
-        <p:cNvPr id="1" name=""/>
-        <p:cNvGrpSpPr/>
-        <p:nvPr/>
-      </p:nvGrpSpPr>
-      <p:grpSpPr>
-        <a:xfrm>
-          <a:off x="0" y="0"/>
-          <a:ext cx="0" cy="0"/>
-          <a:chOff x="0" y="0"/>
-          <a:chExt cx="0" cy="0"/>
-        </a:xfrm>
-      </p:grpSpPr>
-      <p:sp>
-        <p:nvSpPr>
-          <p:cNvPr id="2" name="Text 0"/>
-          <p:cNvSpPr/>
-          <p:nvPr>
-            <p:ph idx="100" type="body" hasCustomPrompt="1"/>
-          </p:nvPr>
-        </p:nvSpPr>
-        <p:spPr>
-          <a:xfrm>
-            <a:off x="457200" y="228600"/>
-            <a:ext cx="8229600" cy="274320"/>
-          </a:xfrm>
-          <a:prstGeom prst="rect">
-            <a:avLst/>
-          </a:prstGeom>
-          <a:noFill/>
-          <a:ln/>
-        </p:spPr>
-        <p:txBody>
-          <a:bodyPr wrap="square" rtlCol="0"/>
-          <a:lstStyle>
-            <a:lvl1pPr indent="0" marL="0">
-              <a:buNone/>
-              <a:defRPr lang="en-US" sz="1200" b="1" spc="100" kern="0" dirty="0">
-                <a:solidFill>
-                  <a:schemeClr val="accent4"/>
-                </a:solidFill>
-              </a:defRPr>
-            </a:lvl1pPr>
-          </a:lstStyle>
-          <a:p>
-            <a:pPr indent="0" marL="0">
+            <a:pPr algn="l" indent="0" marL="0">
               <a:buNone/>
             </a:pPr>
-            <a:endParaRPr lang="en-US" sz="1200" dirty="0"/>
-          </a:p>
-        </p:txBody>
-      </p:sp>
-      <p:sp>
-        <p:nvSpPr>
-          <p:cNvPr id="3" name="Text 0"/>
-          <p:cNvSpPr/>
-          <p:nvPr>
-            <p:ph idx="101" type="title" hasCustomPrompt="1"/>
-          </p:nvPr>
-        </p:nvSpPr>
-        <p:spPr>
-          <a:xfrm>
-            <a:off x="457200" y="502920"/>
-            <a:ext cx="8229600" cy="640080"/>
-          </a:xfrm>
-          <a:prstGeom prst="rect">
-            <a:avLst/>
-          </a:prstGeom>
-          <a:noFill/>
-          <a:ln/>
-        </p:spPr>
-        <p:txBody>
-          <a:bodyPr wrap="square" rtlCol="0"/>
-          <a:lstStyle>
-            <a:lvl1pPr algn="l" indent="0" marL="0">
-              <a:buNone/>
-              <a:defRPr lang="en-US" sz="2800" b="1" dirty="0">
-                <a:solidFill>
-                  <a:schemeClr val="tx1"/>
-                </a:solidFill>
-              </a:defRPr>
-            </a:lvl1pPr>
-          </a:lstStyle>
-          <a:p>
-            <a:pPr algn="l" indent="0" marL="0">
-              <a:buNone/>
-            </a:pPr>
-            <a:endParaRPr lang="en-US" sz="2800" dirty="0"/>
-          </a:p>
-        </p:txBody>
-      </p:sp>
-      <p:sp>
-        <p:nvSpPr>
-          <p:cNvPr id="25" name="Slide Number Placeholder 0"/>
-          <p:cNvSpPr>
-            <a:spLocks noGrp="1"/>
-          </p:cNvSpPr>
-          <p:nvPr>
-            <p:ph type="sldNum" sz="quarter" idx="4294967295"/>
-          </p:nvPr>
-        </p:nvSpPr>
-        <p:spPr>
-          <a:xfrm>
-            <a:off x="8412480" y="4754880"/>
-            <a:ext cx="457200" cy="274320"/>
-          </a:xfrm>
-          <a:prstGeom prst="rect">
-            <a:avLst/>
-          </a:prstGeom>
-          <a:extLst>
-            <a:ext uri="{C572A759-6A51-4108-AA02-DFA0A04FC94B}">
-              <ma14:wrappingTextBoxFlag xmlns:ma14="http://schemas.microsoft.com/office/mac/drawingml/2011/main" val="0"/>
-            </a:ext>
-          </a:extLst>
-        </p:spPr>
-        <p:txBody>
-          <a:bodyPr/>
-          <a:lstStyle>
-            <a:lvl1pPr>
-              <a:defRPr sz="1000">
-                <a:solidFill>
-                  <a:schemeClr val="accent4"/>
-                </a:solidFill>
-              </a:defRPr>
-            </a:lvl1pPr>
-          </a:lstStyle>
-          <a:p>
-            <a:pPr algn="r"/>
-            <a:fld id="{F7021451-1387-4CA6-816F-3879F97B5CBC}" type="slidenum">
-              <a:rPr b="0" lang="en-US"/>
-              <a:t>1004</a:t>
-            </a:fld>
-            <a:endParaRPr lang="en-US"/>
+            <a:endParaRPr lang="en-US" sz="1800" dirty="0"/>
           </a:p>
         </p:txBody>
       </p:sp>
@@ -1115,59 +830,12 @@
           <a:chExt cx="0" cy="0"/>
         </a:xfrm>
       </p:grpSpPr>
-      <p:sp>
-        <p:nvSpPr>
-          <p:cNvPr id="25" name="Slide Number Placeholder 0"/>
-          <p:cNvSpPr>
-            <a:spLocks noGrp="1"/>
-          </p:cNvSpPr>
-          <p:nvPr>
-            <p:ph type="sldNum" sz="quarter" idx="4294967295"/>
-          </p:nvPr>
-        </p:nvSpPr>
-        <p:spPr>
-          <a:xfrm>
-            <a:off x="8412480" y="4754880"/>
-            <a:ext cx="457200" cy="274320"/>
-          </a:xfrm>
-          <a:prstGeom prst="rect">
-            <a:avLst/>
-          </a:prstGeom>
-          <a:extLst>
-            <a:ext uri="{C572A759-6A51-4108-AA02-DFA0A04FC94B}">
-              <ma14:wrappingTextBoxFlag xmlns:ma14="http://schemas.microsoft.com/office/mac/drawingml/2011/main" val="0"/>
-            </a:ext>
-          </a:extLst>
-        </p:spPr>
-        <p:txBody>
-          <a:bodyPr/>
-          <a:lstStyle>
-            <a:lvl1pPr>
-              <a:defRPr sz="1000">
-                <a:solidFill>
-                  <a:schemeClr val="accent4"/>
-                </a:solidFill>
-              </a:defRPr>
-            </a:lvl1pPr>
-          </a:lstStyle>
-          <a:p>
-            <a:pPr algn="r"/>
-            <a:fld id="{F7021451-1387-4CA6-816F-3879F97B5CBC}" type="slidenum">
-              <a:rPr b="0" lang="en-US"/>
-              <a:t>null</a:t>
-            </a:fld>
-            <a:endParaRPr lang="en-US"/>
-          </a:p>
-        </p:txBody>
-      </p:sp>
     </p:spTree>
   </p:cSld>
   <p:clrMap bg1="lt1" tx1="dk1" bg2="lt2" tx2="dk2" accent1="accent1" accent2="accent2" accent3="accent3" accent4="accent4" accent5="accent5" accent6="accent6" hlink="hlink" folHlink="folHlink"/>
   <p:sldLayoutIdLst>
     <p:sldLayoutId id="2147483649" r:id="rId1"/>
     <p:sldLayoutId id="2147483650" r:id="rId2"/>
-    <p:sldLayoutId id="2147483651" r:id="rId3"/>
-    <p:sldLayoutId id="2147483652" r:id="rId4"/>
   </p:sldLayoutIdLst>
   <p:hf sldNum="0" hdr="0" ftr="0" dt="0"/>
   <p:txStyles>
@@ -1442,45 +1110,7 @@
       </p:grpSpPr>
       <p:sp>
         <p:nvSpPr>
-          <p:cNvPr id="2" name="Text 0"/>
-          <p:cNvSpPr/>
-          <p:nvPr>
-            <p:ph idx="100" type="body" hasCustomPrompt="1"/>
-          </p:nvPr>
-        </p:nvSpPr>
-        <p:spPr>
-          <a:xfrm>
-            <a:off x="457200" y="228600"/>
-            <a:ext cx="8229600" cy="274320"/>
-          </a:xfrm>
-          <a:prstGeom prst="rect">
-            <a:avLst/>
-          </a:prstGeom>
-          <a:noFill/>
-          <a:ln/>
-        </p:spPr>
-        <p:txBody>
-          <a:bodyPr wrap="square" lIns="0" tIns="0" rIns="0" bIns="0" rtlCol="0"/>
-          <a:lstStyle/>
-          <a:p>
-            <a:pPr indent="0" marL="0">
-              <a:buNone/>
-            </a:pPr>
-            <a:r>
-              <a:rPr lang="en-US" sz="1200" b="1" spc="100" kern="0" dirty="0">
-                <a:solidFill>
-                  <a:schemeClr val="accent4"/>
-                </a:solidFill>
-              </a:rPr>
-              <a:t>8. RISQUES FINANCIERS, HUMAINS ET RÉPUTATIONNELS</a:t>
-            </a:r>
-            <a:endParaRPr lang="en-US" sz="1200" dirty="0"/>
-          </a:p>
-        </p:txBody>
-      </p:sp>
-      <p:sp>
-        <p:nvSpPr>
-          <p:cNvPr id="3" name="Text 0"/>
+          <p:cNvPr id="2" name="Text 1"/>
           <p:cNvSpPr/>
           <p:nvPr>
             <p:ph idx="101" type="title" hasCustomPrompt="1"/>
@@ -1488,8 +1118,8 @@
         </p:nvSpPr>
         <p:spPr>
           <a:xfrm>
-            <a:off x="457200" y="502920"/>
-            <a:ext cx="8229600" cy="640080"/>
+            <a:off x="411480" y="0"/>
+            <a:ext cx="8321040" cy="786384"/>
           </a:xfrm>
           <a:prstGeom prst="rect">
             <a:avLst/>
@@ -1505,14 +1135,52 @@
               <a:buNone/>
             </a:pPr>
             <a:r>
-              <a:rPr lang="en-US" sz="2800" b="1" dirty="0">
+              <a:rPr lang="en-US" sz="2600" b="1" dirty="0">
                 <a:solidFill>
-                  <a:schemeClr val="tx1"/>
+                  <a:schemeClr val="bg1"/>
+                </a:solidFill>
+              </a:rPr>
+              <a:t>Risques financiers, humains et réputationnels</a:t>
+            </a:r>
+            <a:endParaRPr lang="en-US" sz="2600" dirty="0"/>
+          </a:p>
+        </p:txBody>
+      </p:sp>
+      <p:sp>
+        <p:nvSpPr>
+          <p:cNvPr id="3" name="Text 1"/>
+          <p:cNvSpPr/>
+          <p:nvPr>
+            <p:ph idx="102" type="body" hasCustomPrompt="1"/>
+          </p:nvPr>
+        </p:nvSpPr>
+        <p:spPr>
+          <a:xfrm>
+            <a:off x="411480" y="914400"/>
+            <a:ext cx="8321040" cy="411480"/>
+          </a:xfrm>
+          <a:prstGeom prst="rect">
+            <a:avLst/>
+          </a:prstGeom>
+          <a:noFill/>
+          <a:ln/>
+        </p:spPr>
+        <p:txBody>
+          <a:bodyPr wrap="square" lIns="0" tIns="0" rIns="0" bIns="0" rtlCol="0" anchor="ctr"/>
+          <a:lstStyle/>
+          <a:p>
+            <a:pPr algn="l" indent="0" marL="0">
+              <a:buNone/>
+            </a:pPr>
+            <a:r>
+              <a:rPr lang="en-US" sz="1800" b="1" dirty="0">
+                <a:solidFill>
+                  <a:schemeClr val="accent1"/>
                 </a:solidFill>
               </a:rPr>
               <a:t>Un accès au marché indien sous contraintes</a:t>
             </a:r>
-            <a:endParaRPr lang="en-US" sz="2800" dirty="0"/>
+            <a:endParaRPr lang="en-US" sz="1800" dirty="0"/>
           </a:p>
         </p:txBody>
       </p:sp>
@@ -1524,20 +1192,20 @@
         </p:nvSpPr>
         <p:spPr>
           <a:xfrm>
-            <a:off x="457200" y="1325880"/>
-            <a:ext cx="3977640" cy="3200400"/>
+            <a:off x="411480" y="1463040"/>
+            <a:ext cx="4069080" cy="2606040"/>
           </a:xfrm>
           <a:prstGeom prst="roundRect">
             <a:avLst>
-              <a:gd name="adj" fmla="val 2286"/>
+              <a:gd name="adj" fmla="val 2807"/>
             </a:avLst>
           </a:prstGeom>
           <a:solidFill>
-            <a:schemeClr val="accent6"/>
+            <a:schemeClr val="bg2"/>
           </a:solidFill>
           <a:ln w="12700">
             <a:solidFill>
-              <a:schemeClr val="accent6"/>
+              <a:schemeClr val="bg2"/>
             </a:solidFill>
             <a:prstDash val="solid"/>
           </a:ln>
@@ -1551,18 +1219,18 @@
         </p:nvSpPr>
         <p:spPr>
           <a:xfrm>
-            <a:off x="685800" y="1554480"/>
-            <a:ext cx="685800" cy="685800"/>
+            <a:off x="594360" y="1627632"/>
+            <a:ext cx="640080" cy="640080"/>
           </a:xfrm>
           <a:prstGeom prst="ellipse">
             <a:avLst/>
           </a:prstGeom>
           <a:solidFill>
-            <a:schemeClr val="accent2"/>
+            <a:schemeClr val="accent5"/>
           </a:solidFill>
           <a:ln w="12700">
             <a:solidFill>
-              <a:schemeClr val="accent2"/>
+              <a:schemeClr val="accent5"/>
             </a:solidFill>
             <a:prstDash val="solid"/>
           </a:ln>
@@ -1584,8 +1252,8 @@
         </p:blipFill>
         <p:spPr>
           <a:xfrm>
-            <a:off x="864108" y="1732788"/>
-            <a:ext cx="329184" cy="329184"/>
+            <a:off x="754380" y="1787652"/>
+            <a:ext cx="320040" cy="320040"/>
           </a:xfrm>
           <a:prstGeom prst="rect">
             <a:avLst/>
@@ -1600,8 +1268,8 @@
         </p:nvSpPr>
         <p:spPr>
           <a:xfrm>
-            <a:off x="1508760" y="1508760"/>
-            <a:ext cx="2743200" cy="777240"/>
+            <a:off x="1371600" y="1600200"/>
+            <a:ext cx="2971800" cy="694944"/>
           </a:xfrm>
           <a:prstGeom prst="rect">
             <a:avLst/>
@@ -1617,14 +1285,14 @@
               <a:buNone/>
             </a:pPr>
             <a:r>
-              <a:rPr lang="en-US" sz="1800" b="1" dirty="0">
+              <a:rPr lang="en-US" sz="1700" b="1" dirty="0">
                 <a:solidFill>
-                  <a:schemeClr val="tx1"/>
+                  <a:schemeClr val="accent2"/>
                 </a:solidFill>
               </a:rPr>
               <a:t>Politique « Make in India »</a:t>
             </a:r>
-            <a:endParaRPr lang="en-US" sz="1800" dirty="0"/>
+            <a:endParaRPr lang="en-US" sz="1700" dirty="0"/>
           </a:p>
           <a:p>
             <a:pPr indent="0" marL="0">
@@ -1638,7 +1306,7 @@
               </a:rPr>
               <a:t>L'Inde favorise la production locale</a:t>
             </a:r>
-            <a:endParaRPr lang="en-US" sz="1800" dirty="0"/>
+            <a:endParaRPr lang="en-US" sz="1700" dirty="0"/>
           </a:p>
         </p:txBody>
       </p:sp>
@@ -1650,8 +1318,8 @@
         </p:nvSpPr>
         <p:spPr>
           <a:xfrm>
-            <a:off x="685800" y="2514600"/>
-            <a:ext cx="3566160" cy="365760"/>
+            <a:off x="594360" y="2423160"/>
+            <a:ext cx="3749040" cy="320040"/>
           </a:xfrm>
           <a:prstGeom prst="rect">
             <a:avLst/>
@@ -1686,18 +1354,18 @@
         </p:nvSpPr>
         <p:spPr>
           <a:xfrm>
-            <a:off x="822960" y="3017520"/>
-            <a:ext cx="457200" cy="457200"/>
+            <a:off x="731520" y="2834640"/>
+            <a:ext cx="420624" cy="420624"/>
           </a:xfrm>
           <a:prstGeom prst="ellipse">
             <a:avLst/>
           </a:prstGeom>
           <a:solidFill>
-            <a:schemeClr val="accent2"/>
+            <a:schemeClr val="accent1"/>
           </a:solidFill>
           <a:ln w="12700">
             <a:solidFill>
-              <a:schemeClr val="accent2"/>
+              <a:schemeClr val="accent1"/>
             </a:solidFill>
             <a:prstDash val="solid"/>
           </a:ln>
@@ -1719,8 +1387,8 @@
         </p:blipFill>
         <p:spPr>
           <a:xfrm>
-            <a:off x="941832" y="3136392"/>
-            <a:ext cx="219456" cy="219456"/>
+            <a:off x="836676" y="2939796"/>
+            <a:ext cx="210312" cy="210312"/>
           </a:xfrm>
           <a:prstGeom prst="rect">
             <a:avLst/>
@@ -1735,8 +1403,8 @@
         </p:nvSpPr>
         <p:spPr>
           <a:xfrm>
-            <a:off x="1463040" y="3017520"/>
-            <a:ext cx="2743200" cy="457200"/>
+            <a:off x="1325880" y="2834640"/>
+            <a:ext cx="2926080" cy="420624"/>
           </a:xfrm>
           <a:prstGeom prst="rect">
             <a:avLst/>
@@ -1752,14 +1420,14 @@
               <a:buNone/>
             </a:pPr>
             <a:r>
-              <a:rPr lang="en-US" sz="1600" b="1" dirty="0">
+              <a:rPr lang="en-US" sz="1500" b="1" dirty="0">
                 <a:solidFill>
                   <a:schemeClr val="tx1"/>
                 </a:solidFill>
               </a:rPr>
               <a:t>un partenariat local</a:t>
             </a:r>
-            <a:endParaRPr lang="en-US" sz="1600" dirty="0"/>
+            <a:endParaRPr lang="en-US" sz="1500" dirty="0"/>
           </a:p>
         </p:txBody>
       </p:sp>
@@ -1771,18 +1439,18 @@
         </p:nvSpPr>
         <p:spPr>
           <a:xfrm>
-            <a:off x="822960" y="3703320"/>
-            <a:ext cx="457200" cy="457200"/>
+            <a:off x="731520" y="3401568"/>
+            <a:ext cx="420624" cy="420624"/>
           </a:xfrm>
           <a:prstGeom prst="ellipse">
             <a:avLst/>
           </a:prstGeom>
           <a:solidFill>
-            <a:schemeClr val="accent2"/>
+            <a:schemeClr val="accent1"/>
           </a:solidFill>
           <a:ln w="12700">
             <a:solidFill>
-              <a:schemeClr val="accent2"/>
+              <a:schemeClr val="accent1"/>
             </a:solidFill>
             <a:prstDash val="solid"/>
           </a:ln>
@@ -1804,8 +1472,8 @@
         </p:blipFill>
         <p:spPr>
           <a:xfrm>
-            <a:off x="941832" y="3822192"/>
-            <a:ext cx="219456" cy="219456"/>
+            <a:off x="836676" y="3506724"/>
+            <a:ext cx="210312" cy="210312"/>
           </a:xfrm>
           <a:prstGeom prst="rect">
             <a:avLst/>
@@ -1820,8 +1488,8 @@
         </p:nvSpPr>
         <p:spPr>
           <a:xfrm>
-            <a:off x="1463040" y="3703320"/>
-            <a:ext cx="2743200" cy="457200"/>
+            <a:off x="1325880" y="3401568"/>
+            <a:ext cx="2926080" cy="420624"/>
           </a:xfrm>
           <a:prstGeom prst="rect">
             <a:avLst/>
@@ -1837,14 +1505,14 @@
               <a:buNone/>
             </a:pPr>
             <a:r>
-              <a:rPr lang="en-US" sz="1600" b="1" dirty="0">
+              <a:rPr lang="en-US" sz="1500" b="1" dirty="0">
                 <a:solidFill>
                   <a:schemeClr val="tx1"/>
                 </a:solidFill>
               </a:rPr>
               <a:t>un assemblage sur place</a:t>
             </a:r>
-            <a:endParaRPr lang="en-US" sz="1600" dirty="0"/>
+            <a:endParaRPr lang="en-US" sz="1500" dirty="0"/>
           </a:p>
         </p:txBody>
       </p:sp>
@@ -1856,13 +1524,38 @@
         </p:nvSpPr>
         <p:spPr>
           <a:xfrm>
-            <a:off x="4709160" y="1325880"/>
-            <a:ext cx="3977640" cy="3200400"/>
+            <a:off x="4663440" y="1463040"/>
+            <a:ext cx="4069080" cy="2606040"/>
           </a:xfrm>
           <a:prstGeom prst="roundRect">
             <a:avLst>
-              <a:gd name="adj" fmla="val 2286"/>
+              <a:gd name="adj" fmla="val 2807"/>
             </a:avLst>
+          </a:prstGeom>
+          <a:solidFill>
+            <a:schemeClr val="bg2"/>
+          </a:solidFill>
+          <a:ln w="12700">
+            <a:solidFill>
+              <a:schemeClr val="bg2"/>
+            </a:solidFill>
+            <a:prstDash val="solid"/>
+          </a:ln>
+        </p:spPr>
+      </p:sp>
+      <p:sp>
+        <p:nvSpPr>
+          <p:cNvPr id="16" name="Accord UE-Inde cercle"/>
+          <p:cNvSpPr/>
+          <p:nvPr/>
+        </p:nvSpPr>
+        <p:spPr>
+          <a:xfrm>
+            <a:off x="4846320" y="1627632"/>
+            <a:ext cx="640080" cy="640080"/>
+          </a:xfrm>
+          <a:prstGeom prst="ellipse">
+            <a:avLst/>
           </a:prstGeom>
           <a:solidFill>
             <a:schemeClr val="accent5"/>
@@ -1870,31 +1563,6 @@
           <a:ln w="12700">
             <a:solidFill>
               <a:schemeClr val="accent5"/>
-            </a:solidFill>
-            <a:prstDash val="solid"/>
-          </a:ln>
-        </p:spPr>
-      </p:sp>
-      <p:sp>
-        <p:nvSpPr>
-          <p:cNvPr id="16" name="Accord UE-Inde cercle"/>
-          <p:cNvSpPr/>
-          <p:nvPr/>
-        </p:nvSpPr>
-        <p:spPr>
-          <a:xfrm>
-            <a:off x="4937760" y="1554480"/>
-            <a:ext cx="685800" cy="685800"/>
-          </a:xfrm>
-          <a:prstGeom prst="ellipse">
-            <a:avLst/>
-          </a:prstGeom>
-          <a:solidFill>
-            <a:schemeClr val="accent1"/>
-          </a:solidFill>
-          <a:ln w="12700">
-            <a:solidFill>
-              <a:schemeClr val="accent1"/>
             </a:solidFill>
             <a:prstDash val="solid"/>
           </a:ln>
@@ -1916,8 +1584,8 @@
         </p:blipFill>
         <p:spPr>
           <a:xfrm>
-            <a:off x="5116068" y="1732788"/>
-            <a:ext cx="329184" cy="329184"/>
+            <a:off x="5006340" y="1787652"/>
+            <a:ext cx="320040" cy="320040"/>
           </a:xfrm>
           <a:prstGeom prst="rect">
             <a:avLst/>
@@ -1932,8 +1600,8 @@
         </p:nvSpPr>
         <p:spPr>
           <a:xfrm>
-            <a:off x="5760720" y="1508760"/>
-            <a:ext cx="2743200" cy="777240"/>
+            <a:off x="5623560" y="1600200"/>
+            <a:ext cx="2971800" cy="694944"/>
           </a:xfrm>
           <a:prstGeom prst="rect">
             <a:avLst/>
@@ -1949,14 +1617,14 @@
               <a:buNone/>
             </a:pPr>
             <a:r>
-              <a:rPr lang="en-US" sz="1800" b="1" dirty="0">
+              <a:rPr lang="en-US" sz="1700" b="1" dirty="0">
                 <a:solidFill>
-                  <a:schemeClr val="tx1"/>
+                  <a:schemeClr val="accent2"/>
                 </a:solidFill>
               </a:rPr>
               <a:t>Accord UE-Inde</a:t>
             </a:r>
-            <a:endParaRPr lang="en-US" sz="1800" dirty="0"/>
+            <a:endParaRPr lang="en-US" sz="1700" dirty="0"/>
           </a:p>
           <a:p>
             <a:pPr indent="0" marL="0">
@@ -1970,20 +1638,92 @@
               </a:rPr>
               <a:t>Pas encore en vigueur</a:t>
             </a:r>
-            <a:endParaRPr lang="en-US" sz="1800" dirty="0"/>
-          </a:p>
-        </p:txBody>
-      </p:sp>
-      <p:sp>
-        <p:nvSpPr>
-          <p:cNvPr id="19" name="Frise"/>
+            <a:endParaRPr lang="en-US" sz="1700" dirty="0"/>
+          </a:p>
+        </p:txBody>
+      </p:sp>
+      <p:sp>
+        <p:nvSpPr>
+          <p:cNvPr id="19" name="Text 13"/>
+          <p:cNvSpPr txBox="1"/>
+          <p:nvPr/>
+        </p:nvSpPr>
+        <p:spPr>
+          <a:xfrm>
+            <a:off x="4846320" y="2423160"/>
+            <a:ext cx="1005840" cy="274320"/>
+          </a:xfrm>
+          <a:prstGeom prst="rect">
+            <a:avLst/>
+          </a:prstGeom>
+          <a:noFill/>
+          <a:ln/>
+        </p:spPr>
+        <p:txBody>
+          <a:bodyPr wrap="square" lIns="0" tIns="0" rIns="0" bIns="0" rtlCol="0" anchor="ctr"/>
+          <a:lstStyle/>
+          <a:p>
+            <a:pPr indent="0" marL="0">
+              <a:buNone/>
+            </a:pPr>
+            <a:r>
+              <a:rPr lang="en-US" sz="1300" b="1" dirty="0">
+                <a:solidFill>
+                  <a:schemeClr val="tx1"/>
+                </a:solidFill>
+              </a:rPr>
+              <a:t>Aujourd'hui</a:t>
+            </a:r>
+            <a:endParaRPr lang="en-US" sz="1300" dirty="0"/>
+          </a:p>
+        </p:txBody>
+      </p:sp>
+      <p:sp>
+        <p:nvSpPr>
+          <p:cNvPr id="20" name="Text 14"/>
+          <p:cNvSpPr txBox="1"/>
+          <p:nvPr/>
+        </p:nvSpPr>
+        <p:spPr>
+          <a:xfrm>
+            <a:off x="7635240" y="2423160"/>
+            <a:ext cx="914400" cy="274320"/>
+          </a:xfrm>
+          <a:prstGeom prst="rect">
+            <a:avLst/>
+          </a:prstGeom>
+          <a:noFill/>
+          <a:ln/>
+        </p:spPr>
+        <p:txBody>
+          <a:bodyPr wrap="square" lIns="0" tIns="0" rIns="0" bIns="0" rtlCol="0" anchor="ctr"/>
+          <a:lstStyle/>
+          <a:p>
+            <a:pPr algn="r" indent="0" marL="0">
+              <a:buNone/>
+            </a:pPr>
+            <a:r>
+              <a:rPr lang="en-US" sz="1300" b="1" dirty="0">
+                <a:solidFill>
+                  <a:schemeClr val="accent1"/>
+                </a:solidFill>
+              </a:rPr>
+              <a:t>2027 ?</a:t>
+            </a:r>
+            <a:endParaRPr lang="en-US" sz="1300" dirty="0"/>
+          </a:p>
+        </p:txBody>
+      </p:sp>
+      <p:sp>
+        <p:nvSpPr>
+          <p:cNvPr id="21" name="Frise"/>
           <p:cNvSpPr/>
           <p:nvPr/>
         </p:nvSpPr>
         <p:spPr>
           <a:xfrm>
-            <a:off x="5212080" y="2971800"/>
-            <a:ext cx="3017520" cy="0"/>
+            <a:off x="5120640" y="2880360"/>
+            <a:ext cx="3200400" cy="0"/>
           </a:xfrm>
           <a:prstGeom prst="line">
             <a:avLst/>
@@ -1999,13 +1739,13 @@
       </p:sp>
       <p:sp>
         <p:nvSpPr>
-          <p:cNvPr id="20" name="Point aujourd'hui"/>
+          <p:cNvPr id="22" name="Point aujourd'hui"/>
           <p:cNvSpPr/>
           <p:nvPr/>
         </p:nvSpPr>
         <p:spPr>
           <a:xfrm>
-            <a:off x="5074920" y="2834640"/>
+            <a:off x="4983480" y="2743200"/>
             <a:ext cx="274320" cy="274320"/>
           </a:xfrm>
           <a:prstGeom prst="ellipse">
@@ -2024,13 +1764,13 @@
       </p:sp>
       <p:sp>
         <p:nvSpPr>
-          <p:cNvPr id="21" name="Point 2027"/>
+          <p:cNvPr id="23" name="Point 2027"/>
           <p:cNvSpPr/>
           <p:nvPr/>
         </p:nvSpPr>
         <p:spPr>
           <a:xfrm>
-            <a:off x="8092440" y="2834640"/>
+            <a:off x="8229600" y="2743200"/>
             <a:ext cx="274320" cy="274320"/>
           </a:xfrm>
           <a:prstGeom prst="ellipse">
@@ -2049,86 +1789,14 @@
       </p:sp>
       <p:sp>
         <p:nvSpPr>
-          <p:cNvPr id="22" name="Text 16"/>
-          <p:cNvSpPr txBox="1"/>
-          <p:nvPr/>
-        </p:nvSpPr>
-        <p:spPr>
-          <a:xfrm>
-            <a:off x="4754880" y="2423160"/>
-            <a:ext cx="914400" cy="320040"/>
-          </a:xfrm>
-          <a:prstGeom prst="rect">
-            <a:avLst/>
-          </a:prstGeom>
-          <a:noFill/>
-          <a:ln/>
-        </p:spPr>
-        <p:txBody>
-          <a:bodyPr wrap="square" lIns="0" tIns="0" rIns="0" bIns="0" rtlCol="0" anchor="ctr"/>
-          <a:lstStyle/>
-          <a:p>
-            <a:pPr algn="ctr" indent="0" marL="0">
-              <a:buNone/>
-            </a:pPr>
-            <a:r>
-              <a:rPr lang="en-US" sz="1300" b="1" dirty="0">
-                <a:solidFill>
-                  <a:schemeClr val="tx1"/>
-                </a:solidFill>
-              </a:rPr>
-              <a:t>Aujourd'hui</a:t>
-            </a:r>
-            <a:endParaRPr lang="en-US" sz="1300" dirty="0"/>
-          </a:p>
-        </p:txBody>
-      </p:sp>
-      <p:sp>
-        <p:nvSpPr>
-          <p:cNvPr id="23" name="Text 17"/>
-          <p:cNvSpPr txBox="1"/>
-          <p:nvPr/>
-        </p:nvSpPr>
-        <p:spPr>
-          <a:xfrm>
-            <a:off x="7772400" y="2423160"/>
-            <a:ext cx="914400" cy="320040"/>
-          </a:xfrm>
-          <a:prstGeom prst="rect">
-            <a:avLst/>
-          </a:prstGeom>
-          <a:noFill/>
-          <a:ln/>
-        </p:spPr>
-        <p:txBody>
-          <a:bodyPr wrap="square" lIns="0" tIns="0" rIns="0" bIns="0" rtlCol="0" anchor="ctr"/>
-          <a:lstStyle/>
-          <a:p>
-            <a:pPr algn="ctr" indent="0" marL="0">
-              <a:buNone/>
-            </a:pPr>
-            <a:r>
-              <a:rPr lang="en-US" sz="1300" b="1" dirty="0">
-                <a:solidFill>
-                  <a:schemeClr val="accent1"/>
-                </a:solidFill>
-              </a:rPr>
-              <a:t>2027 ?</a:t>
-            </a:r>
-            <a:endParaRPr lang="en-US" sz="1300" dirty="0"/>
-          </a:p>
-        </p:txBody>
-      </p:sp>
-      <p:sp>
-        <p:nvSpPr>
           <p:cNvPr id="24" name="Text 18"/>
           <p:cNvSpPr txBox="1"/>
           <p:nvPr/>
         </p:nvSpPr>
         <p:spPr>
           <a:xfrm>
-            <a:off x="4937760" y="3337560"/>
-            <a:ext cx="3520440" cy="1005840"/>
+            <a:off x="4846320" y="3200400"/>
+            <a:ext cx="3703320" cy="731520"/>
           </a:xfrm>
           <a:prstGeom prst="rect">
             <a:avLst/>
@@ -2157,46 +1825,124 @@
       </p:sp>
       <p:sp>
         <p:nvSpPr>
-          <p:cNvPr id="25" name="Slide Number Placeholder 0"/>
-          <p:cNvSpPr>
-            <a:spLocks noGrp="1"/>
-          </p:cNvSpPr>
-          <p:nvPr>
-            <p:ph type="sldNum" sz="quarter" idx="4294967295"/>
-          </p:nvPr>
-        </p:nvSpPr>
-        <p:spPr>
-          <a:xfrm>
-            <a:off x="8412480" y="4754880"/>
-            <a:ext cx="457200" cy="274320"/>
-          </a:xfrm>
-          <a:prstGeom prst="rect">
-            <a:avLst/>
-          </a:prstGeom>
-          <a:extLst>
-            <a:ext uri="{C572A759-6A51-4108-AA02-DFA0A04FC94B}">
-              <ma14:wrappingTextBoxFlag xmlns:ma14="http://schemas.microsoft.com/office/mac/drawingml/2011/main" val="0"/>
-            </a:ext>
-          </a:extLst>
-        </p:spPr>
-        <p:txBody>
-          <a:bodyPr/>
-          <a:lstStyle>
-            <a:lvl1pPr>
-              <a:defRPr sz="1000">
+          <p:cNvPr id="25" name="Message clé"/>
+          <p:cNvSpPr/>
+          <p:nvPr/>
+        </p:nvSpPr>
+        <p:spPr>
+          <a:xfrm>
+            <a:off x="411480" y="4251960"/>
+            <a:ext cx="8321040" cy="621792"/>
+          </a:xfrm>
+          <a:prstGeom prst="roundRect">
+            <a:avLst>
+              <a:gd name="adj" fmla="val 11765"/>
+            </a:avLst>
+          </a:prstGeom>
+          <a:solidFill>
+            <a:schemeClr val="bg2"/>
+          </a:solidFill>
+          <a:ln w="12700">
+            <a:solidFill>
+              <a:schemeClr val="bg2"/>
+            </a:solidFill>
+            <a:prstDash val="solid"/>
+          </a:ln>
+        </p:spPr>
+      </p:sp>
+      <p:sp>
+        <p:nvSpPr>
+          <p:cNvPr id="26" name="Message clé cercle"/>
+          <p:cNvSpPr/>
+          <p:nvPr/>
+        </p:nvSpPr>
+        <p:spPr>
+          <a:xfrm>
+            <a:off x="566928" y="4334256"/>
+            <a:ext cx="457200" cy="457200"/>
+          </a:xfrm>
+          <a:prstGeom prst="ellipse">
+            <a:avLst/>
+          </a:prstGeom>
+          <a:solidFill>
+            <a:schemeClr val="accent1"/>
+          </a:solidFill>
+          <a:ln w="12700">
+            <a:solidFill>
+              <a:schemeClr val="accent1"/>
+            </a:solidFill>
+            <a:prstDash val="solid"/>
+          </a:ln>
+        </p:spPr>
+      </p:sp>
+      <p:pic>
+        <p:nvPicPr>
+          <p:cNvPr id="27" name="Message clé icône" descr="Message clé">    </p:cNvPr>
+          <p:cNvPicPr>
+            <a:picLocks noChangeAspect="1"/>
+          </p:cNvPicPr>
+          <p:nvPr/>
+        </p:nvPicPr>
+        <p:blipFill>
+          <a:blip r:embed="rId5"/>
+          <a:stretch>
+            <a:fillRect/>
+          </a:stretch>
+        </p:blipFill>
+        <p:spPr>
+          <a:xfrm>
+            <a:off x="681228" y="4448556"/>
+            <a:ext cx="228600" cy="228600"/>
+          </a:xfrm>
+          <a:prstGeom prst="rect">
+            <a:avLst/>
+          </a:prstGeom>
+        </p:spPr>
+      </p:pic>
+      <p:sp>
+        <p:nvSpPr>
+          <p:cNvPr id="28" name="Text 21"/>
+          <p:cNvSpPr txBox="1"/>
+          <p:nvPr/>
+        </p:nvSpPr>
+        <p:spPr>
+          <a:xfrm>
+            <a:off x="1188720" y="4251960"/>
+            <a:ext cx="7406640" cy="621792"/>
+          </a:xfrm>
+          <a:prstGeom prst="rect">
+            <a:avLst/>
+          </a:prstGeom>
+          <a:noFill/>
+          <a:ln/>
+        </p:spPr>
+        <p:txBody>
+          <a:bodyPr wrap="square" lIns="0" tIns="0" rIns="0" bIns="0" rtlCol="0" anchor="ctr"/>
+          <a:lstStyle/>
+          <a:p>
+            <a:pPr indent="0" marL="0">
+              <a:buNone/>
+            </a:pPr>
+            <a:r>
+              <a:rPr lang="en-US" sz="1400" b="1" dirty="0">
                 <a:solidFill>
-                  <a:schemeClr val="accent4"/>
+                  <a:schemeClr val="tx1"/>
                 </a:solidFill>
-              </a:defRPr>
-            </a:lvl1pPr>
-          </a:lstStyle>
-          <a:p>
-            <a:pPr algn="r"/>
-            <a:fld id="{F7021451-1387-4CA6-816F-3879F97B5CBC}" type="slidenum">
-              <a:rPr b="0" lang="en-US"/>
-              <a:t>1</a:t>
-            </a:fld>
-            <a:endParaRPr lang="en-US"/>
+              </a:rPr>
+              <a:t>Message clé  </a:t>
+            </a:r>
+            <a:pPr indent="0" marL="0">
+              <a:buNone/>
+            </a:pPr>
+            <a:r>
+              <a:rPr lang="en-US" sz="1400" dirty="0">
+                <a:solidFill>
+                  <a:schemeClr val="tx1"/>
+                </a:solidFill>
+              </a:rPr>
+              <a:t>Entrer en Inde impose d'adapter le modèle d'implantation de LMT.</a:t>
+            </a:r>
+            <a:endParaRPr lang="en-US" sz="1400" dirty="0"/>
           </a:p>
         </p:txBody>
       </p:sp>
@@ -2227,45 +1973,7 @@
       </p:grpSpPr>
       <p:sp>
         <p:nvSpPr>
-          <p:cNvPr id="2" name="Text 0"/>
-          <p:cNvSpPr/>
-          <p:nvPr>
-            <p:ph idx="100" type="body" hasCustomPrompt="1"/>
-          </p:nvPr>
-        </p:nvSpPr>
-        <p:spPr>
-          <a:xfrm>
-            <a:off x="457200" y="228600"/>
-            <a:ext cx="8229600" cy="274320"/>
-          </a:xfrm>
-          <a:prstGeom prst="rect">
-            <a:avLst/>
-          </a:prstGeom>
-          <a:noFill/>
-          <a:ln/>
-        </p:spPr>
-        <p:txBody>
-          <a:bodyPr wrap="square" lIns="0" tIns="0" rIns="0" bIns="0" rtlCol="0"/>
-          <a:lstStyle/>
-          <a:p>
-            <a:pPr indent="0" marL="0">
-              <a:buNone/>
-            </a:pPr>
-            <a:r>
-              <a:rPr lang="en-US" sz="1200" b="1" spc="100" kern="0" dirty="0">
-                <a:solidFill>
-                  <a:schemeClr val="accent4"/>
-                </a:solidFill>
-              </a:rPr>
-              <a:t>8. RISQUES FINANCIERS, HUMAINS ET RÉPUTATIONNELS</a:t>
-            </a:r>
-            <a:endParaRPr lang="en-US" sz="1200" dirty="0"/>
-          </a:p>
-        </p:txBody>
-      </p:sp>
-      <p:sp>
-        <p:nvSpPr>
-          <p:cNvPr id="3" name="Text 0"/>
+          <p:cNvPr id="2" name="Text 1"/>
           <p:cNvSpPr/>
           <p:nvPr>
             <p:ph idx="101" type="title" hasCustomPrompt="1"/>
@@ -2273,8 +1981,8 @@
         </p:nvSpPr>
         <p:spPr>
           <a:xfrm>
-            <a:off x="457200" y="502920"/>
-            <a:ext cx="8229600" cy="640080"/>
+            <a:off x="411480" y="0"/>
+            <a:ext cx="8321040" cy="786384"/>
           </a:xfrm>
           <a:prstGeom prst="rect">
             <a:avLst/>
@@ -2290,45 +1998,110 @@
               <a:buNone/>
             </a:pPr>
             <a:r>
-              <a:rPr lang="en-US" sz="2800" b="1" dirty="0">
+              <a:rPr lang="en-US" sz="2600" b="1" dirty="0">
                 <a:solidFill>
-                  <a:schemeClr val="tx1"/>
+                  <a:schemeClr val="bg1"/>
+                </a:solidFill>
+              </a:rPr>
+              <a:t>Risques financiers, humains et réputationnels</a:t>
+            </a:r>
+            <a:endParaRPr lang="en-US" sz="2600" dirty="0"/>
+          </a:p>
+        </p:txBody>
+      </p:sp>
+      <p:sp>
+        <p:nvSpPr>
+          <p:cNvPr id="3" name="Text 1"/>
+          <p:cNvSpPr/>
+          <p:nvPr>
+            <p:ph idx="102" type="body" hasCustomPrompt="1"/>
+          </p:nvPr>
+        </p:nvSpPr>
+        <p:spPr>
+          <a:xfrm>
+            <a:off x="411480" y="914400"/>
+            <a:ext cx="8321040" cy="411480"/>
+          </a:xfrm>
+          <a:prstGeom prst="rect">
+            <a:avLst/>
+          </a:prstGeom>
+          <a:noFill/>
+          <a:ln/>
+        </p:spPr>
+        <p:txBody>
+          <a:bodyPr wrap="square" lIns="0" tIns="0" rIns="0" bIns="0" rtlCol="0" anchor="ctr"/>
+          <a:lstStyle/>
+          <a:p>
+            <a:pPr algn="l" indent="0" marL="0">
+              <a:buNone/>
+            </a:pPr>
+            <a:r>
+              <a:rPr lang="en-US" sz="1800" b="1" dirty="0">
+                <a:solidFill>
+                  <a:schemeClr val="accent1"/>
                 </a:solidFill>
               </a:rPr>
               <a:t>Un risque américain, mais une demande porteuse</a:t>
             </a:r>
-            <a:endParaRPr lang="en-US" sz="2800" dirty="0"/>
-          </a:p>
-        </p:txBody>
-      </p:sp>
-      <p:sp>
-        <p:nvSpPr>
-          <p:cNvPr id="4" name="Risque américain cercle"/>
+            <a:endParaRPr lang="en-US" sz="1800" dirty="0"/>
+          </a:p>
+        </p:txBody>
+      </p:sp>
+      <p:sp>
+        <p:nvSpPr>
+          <p:cNvPr id="4" name="Risque américain"/>
           <p:cNvSpPr/>
           <p:nvPr/>
         </p:nvSpPr>
         <p:spPr>
           <a:xfrm>
-            <a:off x="457200" y="1325880"/>
-            <a:ext cx="548640" cy="548640"/>
-          </a:xfrm>
-          <a:prstGeom prst="ellipse">
-            <a:avLst/>
-          </a:prstGeom>
-          <a:solidFill>
-            <a:schemeClr val="accent3"/>
+            <a:off x="411480" y="1463040"/>
+            <a:ext cx="4434840" cy="2606040"/>
+          </a:xfrm>
+          <a:prstGeom prst="roundRect">
+            <a:avLst>
+              <a:gd name="adj" fmla="val 2807"/>
+            </a:avLst>
+          </a:prstGeom>
+          <a:solidFill>
+            <a:schemeClr val="bg1"/>
           </a:solidFill>
           <a:ln w="12700">
             <a:solidFill>
-              <a:schemeClr val="accent3"/>
+              <a:srgbClr val="C9D8EA"/>
             </a:solidFill>
             <a:prstDash val="solid"/>
           </a:ln>
         </p:spPr>
       </p:sp>
+      <p:sp>
+        <p:nvSpPr>
+          <p:cNvPr id="5" name="Risque américain cercle"/>
+          <p:cNvSpPr/>
+          <p:nvPr/>
+        </p:nvSpPr>
+        <p:spPr>
+          <a:xfrm>
+            <a:off x="594360" y="1600200"/>
+            <a:ext cx="594360" cy="594360"/>
+          </a:xfrm>
+          <a:prstGeom prst="ellipse">
+            <a:avLst/>
+          </a:prstGeom>
+          <a:solidFill>
+            <a:schemeClr val="accent5"/>
+          </a:solidFill>
+          <a:ln w="12700">
+            <a:solidFill>
+              <a:schemeClr val="accent5"/>
+            </a:solidFill>
+            <a:prstDash val="solid"/>
+          </a:ln>
+        </p:spPr>
+      </p:sp>
       <p:pic>
         <p:nvPicPr>
-          <p:cNvPr id="5" name="Risque américain icône" descr="Risque américain">    </p:cNvPr>
+          <p:cNvPr id="6" name="Risque américain icône" descr="Risque américain">    </p:cNvPr>
           <p:cNvPicPr>
             <a:picLocks noChangeAspect="1"/>
           </p:cNvPicPr>
@@ -2342,8 +2115,8 @@
         </p:blipFill>
         <p:spPr>
           <a:xfrm>
-            <a:off x="599846" y="1468526"/>
-            <a:ext cx="263347" cy="263347"/>
+            <a:off x="742950" y="1748790"/>
+            <a:ext cx="297180" cy="297180"/>
           </a:xfrm>
           <a:prstGeom prst="rect">
             <a:avLst/>
@@ -2352,14 +2125,14 @@
       </p:pic>
       <p:sp>
         <p:nvSpPr>
-          <p:cNvPr id="6" name="Text 3"/>
+          <p:cNvPr id="7" name="Text 4"/>
           <p:cNvSpPr txBox="1"/>
           <p:nvPr/>
         </p:nvSpPr>
         <p:spPr>
           <a:xfrm>
-            <a:off x="1143000" y="1280160"/>
-            <a:ext cx="3657600" cy="685800"/>
+            <a:off x="1325880" y="1554480"/>
+            <a:ext cx="3383280" cy="685800"/>
           </a:xfrm>
           <a:prstGeom prst="rect">
             <a:avLst/>
@@ -2375,14 +2148,14 @@
               <a:buNone/>
             </a:pPr>
             <a:r>
-              <a:rPr lang="en-US" sz="1800" b="1" dirty="0">
+              <a:rPr lang="en-US" sz="1700" b="1" dirty="0">
                 <a:solidFill>
-                  <a:schemeClr val="accent3"/>
+                  <a:schemeClr val="accent2"/>
                 </a:solidFill>
               </a:rPr>
               <a:t>Risque américain</a:t>
             </a:r>
-            <a:endParaRPr lang="en-US" sz="1800" dirty="0"/>
+            <a:endParaRPr lang="en-US" sz="1700" dirty="0"/>
           </a:p>
           <a:p>
             <a:pPr indent="0" marL="0">
@@ -2396,24 +2169,24 @@
               </a:rPr>
               <a:t>Droits de douane des États-Unis sur les produits indiens</a:t>
             </a:r>
-            <a:endParaRPr lang="en-US" sz="1800" dirty="0"/>
-          </a:p>
-        </p:txBody>
-      </p:sp>
-      <p:sp>
-        <p:nvSpPr>
-          <p:cNvPr id="7" name="Tarif août 2025"/>
+            <a:endParaRPr lang="en-US" sz="1700" dirty="0"/>
+          </a:p>
+        </p:txBody>
+      </p:sp>
+      <p:sp>
+        <p:nvSpPr>
+          <p:cNvPr id="8" name="Tarif août 2025"/>
           <p:cNvSpPr/>
           <p:nvPr/>
         </p:nvSpPr>
         <p:spPr>
           <a:xfrm>
-            <a:off x="457200" y="2240280"/>
-            <a:ext cx="1920240" cy="1600200"/>
+            <a:off x="640080" y="2423160"/>
+            <a:ext cx="1783080" cy="1417320"/>
           </a:xfrm>
           <a:prstGeom prst="roundRect">
             <a:avLst>
-              <a:gd name="adj" fmla="val 4571"/>
+              <a:gd name="adj" fmla="val 5161"/>
             </a:avLst>
           </a:prstGeom>
           <a:solidFill>
@@ -2429,14 +2202,14 @@
       </p:sp>
       <p:sp>
         <p:nvSpPr>
-          <p:cNvPr id="8" name="Text 5"/>
+          <p:cNvPr id="9" name="Text 6"/>
           <p:cNvSpPr txBox="1"/>
           <p:nvPr/>
         </p:nvSpPr>
         <p:spPr>
           <a:xfrm>
-            <a:off x="457200" y="2240280"/>
-            <a:ext cx="1920240" cy="1600200"/>
+            <a:off x="640080" y="2423160"/>
+            <a:ext cx="1783080" cy="1417320"/>
           </a:xfrm>
           <a:prstGeom prst="rect">
             <a:avLst/>
@@ -2452,45 +2225,45 @@
               <a:buNone/>
             </a:pPr>
             <a:r>
-              <a:rPr lang="en-US" sz="4400" b="1" dirty="0">
+              <a:rPr lang="en-US" sz="3800" b="1" dirty="0">
                 <a:solidFill>
                   <a:schemeClr val="accent3"/>
                 </a:solidFill>
               </a:rPr>
               <a:t>50 %</a:t>
             </a:r>
-            <a:endParaRPr lang="en-US" sz="4400" dirty="0"/>
+            <a:endParaRPr lang="en-US" sz="3800" dirty="0"/>
           </a:p>
           <a:p>
             <a:pPr algn="ctr" indent="0" marL="0">
               <a:buNone/>
             </a:pPr>
             <a:r>
-              <a:rPr lang="en-US" sz="1400" dirty="0">
+              <a:rPr lang="en-US" sz="1300" dirty="0">
                 <a:solidFill>
                   <a:schemeClr val="tx2"/>
                 </a:solidFill>
               </a:rPr>
               <a:t>août 2025</a:t>
             </a:r>
-            <a:endParaRPr lang="en-US" sz="4400" dirty="0"/>
-          </a:p>
-        </p:txBody>
-      </p:sp>
-      <p:sp>
-        <p:nvSpPr>
-          <p:cNvPr id="9" name="Tarif février 2026"/>
+            <a:endParaRPr lang="en-US" sz="3800" dirty="0"/>
+          </a:p>
+        </p:txBody>
+      </p:sp>
+      <p:sp>
+        <p:nvSpPr>
+          <p:cNvPr id="10" name="Tarif février 2026"/>
           <p:cNvSpPr/>
           <p:nvPr/>
         </p:nvSpPr>
         <p:spPr>
           <a:xfrm>
-            <a:off x="2834640" y="2240280"/>
-            <a:ext cx="1920240" cy="1600200"/>
+            <a:off x="2834640" y="2423160"/>
+            <a:ext cx="1783080" cy="1417320"/>
           </a:xfrm>
           <a:prstGeom prst="roundRect">
             <a:avLst>
-              <a:gd name="adj" fmla="val 4571"/>
+              <a:gd name="adj" fmla="val 5161"/>
             </a:avLst>
           </a:prstGeom>
           <a:solidFill>
@@ -2506,14 +2279,14 @@
       </p:sp>
       <p:sp>
         <p:nvSpPr>
-          <p:cNvPr id="10" name="Text 7"/>
+          <p:cNvPr id="11" name="Text 8"/>
           <p:cNvSpPr txBox="1"/>
           <p:nvPr/>
         </p:nvSpPr>
         <p:spPr>
           <a:xfrm>
-            <a:off x="2834640" y="2240280"/>
-            <a:ext cx="1920240" cy="1600200"/>
+            <a:off x="2834640" y="2423160"/>
+            <a:ext cx="1783080" cy="1417320"/>
           </a:xfrm>
           <a:prstGeom prst="rect">
             <a:avLst/>
@@ -2529,34 +2302,34 @@
               <a:buNone/>
             </a:pPr>
             <a:r>
-              <a:rPr lang="en-US" sz="4400" b="1" dirty="0">
+              <a:rPr lang="en-US" sz="3800" b="1" dirty="0">
                 <a:solidFill>
-                  <a:schemeClr val="tx2"/>
+                  <a:schemeClr val="accent1"/>
                 </a:solidFill>
               </a:rPr>
               <a:t>18 %</a:t>
             </a:r>
-            <a:endParaRPr lang="en-US" sz="4400" dirty="0"/>
+            <a:endParaRPr lang="en-US" sz="3800" dirty="0"/>
           </a:p>
           <a:p>
             <a:pPr algn="ctr" indent="0" marL="0">
               <a:buNone/>
             </a:pPr>
             <a:r>
-              <a:rPr lang="en-US" sz="1400" dirty="0">
+              <a:rPr lang="en-US" sz="1300" dirty="0">
                 <a:solidFill>
                   <a:schemeClr val="tx2"/>
                 </a:solidFill>
               </a:rPr>
               <a:t>février 2026</a:t>
             </a:r>
-            <a:endParaRPr lang="en-US" sz="4400" dirty="0"/>
+            <a:endParaRPr lang="en-US" sz="3800" dirty="0"/>
           </a:p>
         </p:txBody>
       </p:sp>
       <p:pic>
         <p:nvPicPr>
-          <p:cNvPr id="11" name="Flèche baisse" descr="flèche">    </p:cNvPr>
+          <p:cNvPr id="12" name="Flèche" descr="flèche">    </p:cNvPr>
           <p:cNvPicPr>
             <a:picLocks noChangeAspect="1"/>
           </p:cNvPicPr>
@@ -2570,50 +2343,14 @@
         </p:blipFill>
         <p:spPr>
           <a:xfrm>
-            <a:off x="2487168" y="2880360"/>
-            <a:ext cx="320040" cy="320040"/>
+            <a:off x="2514600" y="2990088"/>
+            <a:ext cx="274320" cy="274320"/>
           </a:xfrm>
           <a:prstGeom prst="rect">
             <a:avLst/>
           </a:prstGeom>
         </p:spPr>
       </p:pic>
-      <p:sp>
-        <p:nvSpPr>
-          <p:cNvPr id="12" name="Text 8"/>
-          <p:cNvSpPr txBox="1"/>
-          <p:nvPr/>
-        </p:nvSpPr>
-        <p:spPr>
-          <a:xfrm>
-            <a:off x="457200" y="4023360"/>
-            <a:ext cx="4297680" cy="457200"/>
-          </a:xfrm>
-          <a:prstGeom prst="rect">
-            <a:avLst/>
-          </a:prstGeom>
-          <a:noFill/>
-          <a:ln/>
-        </p:spPr>
-        <p:txBody>
-          <a:bodyPr wrap="square" lIns="0" tIns="0" rIns="0" bIns="0" rtlCol="0" anchor="ctr"/>
-          <a:lstStyle/>
-          <a:p>
-            <a:pPr indent="0" marL="0">
-              <a:buNone/>
-            </a:pPr>
-            <a:r>
-              <a:rPr lang="en-US" sz="1400" i="1" dirty="0">
-                <a:solidFill>
-                  <a:schemeClr val="tx1"/>
-                </a:solidFill>
-              </a:rPr>
-              <a:t>Une politique douanière instable qui crée de l'incertitude.</a:t>
-            </a:r>
-            <a:endParaRPr lang="en-US" sz="1400" dirty="0"/>
-          </a:p>
-        </p:txBody>
-      </p:sp>
       <p:sp>
         <p:nvSpPr>
           <p:cNvPr id="13" name="Opportunité"/>
@@ -2622,13 +2359,38 @@
         </p:nvSpPr>
         <p:spPr>
           <a:xfrm>
-            <a:off x="5166360" y="1325880"/>
-            <a:ext cx="3520440" cy="3200400"/>
+            <a:off x="5029200" y="1463040"/>
+            <a:ext cx="3703320" cy="2606040"/>
           </a:xfrm>
           <a:prstGeom prst="roundRect">
             <a:avLst>
-              <a:gd name="adj" fmla="val 2286"/>
+              <a:gd name="adj" fmla="val 2807"/>
             </a:avLst>
+          </a:prstGeom>
+          <a:solidFill>
+            <a:schemeClr val="accent2"/>
+          </a:solidFill>
+          <a:ln w="12700">
+            <a:solidFill>
+              <a:schemeClr val="accent2"/>
+            </a:solidFill>
+            <a:prstDash val="solid"/>
+          </a:ln>
+        </p:spPr>
+      </p:sp>
+      <p:sp>
+        <p:nvSpPr>
+          <p:cNvPr id="14" name="Hôpitaux cercle"/>
+          <p:cNvSpPr/>
+          <p:nvPr/>
+        </p:nvSpPr>
+        <p:spPr>
+          <a:xfrm>
+            <a:off x="5212080" y="1600200"/>
+            <a:ext cx="594360" cy="594360"/>
+          </a:xfrm>
+          <a:prstGeom prst="ellipse">
+            <a:avLst/>
           </a:prstGeom>
           <a:solidFill>
             <a:schemeClr val="accent1"/>
@@ -2641,34 +2403,9 @@
           </a:ln>
         </p:spPr>
       </p:sp>
-      <p:sp>
-        <p:nvSpPr>
-          <p:cNvPr id="14" name="Hôpitaux cercle"/>
-          <p:cNvSpPr/>
-          <p:nvPr/>
-        </p:nvSpPr>
-        <p:spPr>
-          <a:xfrm>
-            <a:off x="5394960" y="1554480"/>
-            <a:ext cx="685800" cy="685800"/>
-          </a:xfrm>
-          <a:prstGeom prst="ellipse">
-            <a:avLst/>
-          </a:prstGeom>
-          <a:solidFill>
-            <a:schemeClr val="bg1"/>
-          </a:solidFill>
-          <a:ln w="12700">
-            <a:solidFill>
-              <a:schemeClr val="bg1"/>
-            </a:solidFill>
-            <a:prstDash val="solid"/>
-          </a:ln>
-        </p:spPr>
-      </p:sp>
       <p:pic>
         <p:nvPicPr>
-          <p:cNvPr id="15" name="Hôpital couleur" descr="hôpital">    </p:cNvPr>
+          <p:cNvPr id="15" name="Hôpitaux icône" descr="Hôpitaux">    </p:cNvPr>
           <p:cNvPicPr>
             <a:picLocks noChangeAspect="1"/>
           </p:cNvPicPr>
@@ -2682,8 +2419,8 @@
         </p:blipFill>
         <p:spPr>
           <a:xfrm>
-            <a:off x="5573268" y="1732788"/>
-            <a:ext cx="329184" cy="329184"/>
+            <a:off x="5360670" y="1748790"/>
+            <a:ext cx="297180" cy="297180"/>
           </a:xfrm>
           <a:prstGeom prst="rect">
             <a:avLst/>
@@ -2698,8 +2435,8 @@
         </p:nvSpPr>
         <p:spPr>
           <a:xfrm>
-            <a:off x="6217920" y="1554480"/>
-            <a:ext cx="2286000" cy="685800"/>
+            <a:off x="5943600" y="1600200"/>
+            <a:ext cx="2651760" cy="594360"/>
           </a:xfrm>
           <a:prstGeom prst="rect">
             <a:avLst/>
@@ -2734,8 +2471,8 @@
         </p:nvSpPr>
         <p:spPr>
           <a:xfrm>
-            <a:off x="5394960" y="2468880"/>
-            <a:ext cx="3108960" cy="1920240"/>
+            <a:off x="5212080" y="2377440"/>
+            <a:ext cx="3337560" cy="1554480"/>
           </a:xfrm>
           <a:prstGeom prst="rect">
             <a:avLst/>
@@ -2765,9 +2502,9 @@
               <a:buNone/>
             </a:pPr>
             <a:r>
-              <a:rPr lang="en-US" sz="800" dirty="0">
+              <a:rPr lang="en-US" sz="600" dirty="0">
                 <a:solidFill>
-                  <a:srgbClr val="000000"/>
+                  <a:schemeClr val="bg1"/>
                 </a:solidFill>
               </a:rPr>
               <a:t> </a:t>
@@ -2792,46 +2529,124 @@
       </p:sp>
       <p:sp>
         <p:nvSpPr>
-          <p:cNvPr id="25" name="Slide Number Placeholder 0"/>
-          <p:cNvSpPr>
-            <a:spLocks noGrp="1"/>
-          </p:cNvSpPr>
-          <p:nvPr>
-            <p:ph type="sldNum" sz="quarter" idx="4294967295"/>
-          </p:nvPr>
-        </p:nvSpPr>
-        <p:spPr>
-          <a:xfrm>
-            <a:off x="8412480" y="4754880"/>
-            <a:ext cx="457200" cy="274320"/>
-          </a:xfrm>
-          <a:prstGeom prst="rect">
-            <a:avLst/>
-          </a:prstGeom>
-          <a:extLst>
-            <a:ext uri="{C572A759-6A51-4108-AA02-DFA0A04FC94B}">
-              <ma14:wrappingTextBoxFlag xmlns:ma14="http://schemas.microsoft.com/office/mac/drawingml/2011/main" val="0"/>
-            </a:ext>
-          </a:extLst>
-        </p:spPr>
-        <p:txBody>
-          <a:bodyPr/>
-          <a:lstStyle>
-            <a:lvl1pPr>
-              <a:defRPr sz="1000">
+          <p:cNvPr id="18" name="Message clé"/>
+          <p:cNvSpPr/>
+          <p:nvPr/>
+        </p:nvSpPr>
+        <p:spPr>
+          <a:xfrm>
+            <a:off x="411480" y="4251960"/>
+            <a:ext cx="8321040" cy="621792"/>
+          </a:xfrm>
+          <a:prstGeom prst="roundRect">
+            <a:avLst>
+              <a:gd name="adj" fmla="val 11765"/>
+            </a:avLst>
+          </a:prstGeom>
+          <a:solidFill>
+            <a:schemeClr val="bg2"/>
+          </a:solidFill>
+          <a:ln w="12700">
+            <a:solidFill>
+              <a:schemeClr val="bg2"/>
+            </a:solidFill>
+            <a:prstDash val="solid"/>
+          </a:ln>
+        </p:spPr>
+      </p:sp>
+      <p:sp>
+        <p:nvSpPr>
+          <p:cNvPr id="19" name="Message clé cercle"/>
+          <p:cNvSpPr/>
+          <p:nvPr/>
+        </p:nvSpPr>
+        <p:spPr>
+          <a:xfrm>
+            <a:off x="566928" y="4334256"/>
+            <a:ext cx="457200" cy="457200"/>
+          </a:xfrm>
+          <a:prstGeom prst="ellipse">
+            <a:avLst/>
+          </a:prstGeom>
+          <a:solidFill>
+            <a:schemeClr val="accent1"/>
+          </a:solidFill>
+          <a:ln w="12700">
+            <a:solidFill>
+              <a:schemeClr val="accent1"/>
+            </a:solidFill>
+            <a:prstDash val="solid"/>
+          </a:ln>
+        </p:spPr>
+      </p:sp>
+      <p:pic>
+        <p:nvPicPr>
+          <p:cNvPr id="20" name="Message clé icône" descr="Message clé">    </p:cNvPr>
+          <p:cNvPicPr>
+            <a:picLocks noChangeAspect="1"/>
+          </p:cNvPicPr>
+          <p:nvPr/>
+        </p:nvPicPr>
+        <p:blipFill>
+          <a:blip r:embed="rId4"/>
+          <a:stretch>
+            <a:fillRect/>
+          </a:stretch>
+        </p:blipFill>
+        <p:spPr>
+          <a:xfrm>
+            <a:off x="681228" y="4448556"/>
+            <a:ext cx="228600" cy="228600"/>
+          </a:xfrm>
+          <a:prstGeom prst="rect">
+            <a:avLst/>
+          </a:prstGeom>
+        </p:spPr>
+      </p:pic>
+      <p:sp>
+        <p:nvSpPr>
+          <p:cNvPr id="21" name="Text 15"/>
+          <p:cNvSpPr txBox="1"/>
+          <p:nvPr/>
+        </p:nvSpPr>
+        <p:spPr>
+          <a:xfrm>
+            <a:off x="1188720" y="4251960"/>
+            <a:ext cx="7406640" cy="621792"/>
+          </a:xfrm>
+          <a:prstGeom prst="rect">
+            <a:avLst/>
+          </a:prstGeom>
+          <a:noFill/>
+          <a:ln/>
+        </p:spPr>
+        <p:txBody>
+          <a:bodyPr wrap="square" lIns="0" tIns="0" rIns="0" bIns="0" rtlCol="0" anchor="ctr"/>
+          <a:lstStyle/>
+          <a:p>
+            <a:pPr indent="0" marL="0">
+              <a:buNone/>
+            </a:pPr>
+            <a:r>
+              <a:rPr lang="en-US" sz="1400" b="1" dirty="0">
                 <a:solidFill>
-                  <a:schemeClr val="accent4"/>
+                  <a:schemeClr val="tx1"/>
                 </a:solidFill>
-              </a:defRPr>
-            </a:lvl1pPr>
-          </a:lstStyle>
-          <a:p>
-            <a:pPr algn="r"/>
-            <a:fld id="{F7021451-1387-4CA6-816F-3879F97B5CBC}" type="slidenum">
-              <a:rPr b="0" lang="en-US"/>
-              <a:t>2</a:t>
-            </a:fld>
-            <a:endParaRPr lang="en-US"/>
+              </a:rPr>
+              <a:t>Message clé  </a:t>
+            </a:r>
+            <a:pPr indent="0" marL="0">
+              <a:buNone/>
+            </a:pPr>
+            <a:r>
+              <a:rPr lang="en-US" sz="1400" dirty="0">
+                <a:solidFill>
+                  <a:schemeClr val="tx1"/>
+                </a:solidFill>
+              </a:rPr>
+              <a:t>Une politique douanière instable, mais un besoin médical réel.</a:t>
+            </a:r>
+            <a:endParaRPr lang="en-US" sz="1400" dirty="0"/>
           </a:p>
         </p:txBody>
       </p:sp>
@@ -2844,47 +2659,47 @@
 </file>
 
 <file path=ppt/theme/theme1.xml><?xml version="1.0" encoding="utf-8"?>
-<a:theme xmlns:a="http://schemas.openxmlformats.org/drawingml/2006/main" name="Risques">
+<a:theme xmlns:a="http://schemas.openxmlformats.org/drawingml/2006/main" name="LMT Inde">
   <a:themeElements>
-    <a:clrScheme name="Risques">
+    <a:clrScheme name="LMT Inde">
       <a:dk1>
-        <a:srgbClr val="1B2430"/>
+        <a:srgbClr val="1F2865"/>
       </a:dk1>
       <a:lt1>
         <a:srgbClr val="FFFFFF"/>
       </a:lt1>
       <a:dk2>
-        <a:srgbClr val="4A5566"/>
+        <a:srgbClr val="3B4A6B"/>
       </a:dk2>
       <a:lt2>
-        <a:srgbClr val="F1F3F6"/>
+        <a:srgbClr val="EAF2FB"/>
       </a:lt2>
       <a:accent1>
-        <a:srgbClr val="1F7A8C"/>
+        <a:srgbClr val="1F5FA8"/>
       </a:accent1>
       <a:accent2>
-        <a:srgbClr val="D9822B"/>
+        <a:srgbClr val="0F3D7A"/>
       </a:accent2>
       <a:accent3>
-        <a:srgbClr val="B83A3A"/>
+        <a:srgbClr val="C0392B"/>
       </a:accent3>
       <a:accent4>
-        <a:srgbClr val="6C7A89"/>
+        <a:srgbClr val="6B7A90"/>
       </a:accent4>
       <a:accent5>
-        <a:srgbClr val="DCEDF1"/>
+        <a:srgbClr val="D6E6F7"/>
       </a:accent5>
       <a:accent6>
-        <a:srgbClr val="FBEBDA"/>
+        <a:srgbClr val="E8873A"/>
       </a:accent6>
       <a:hlink>
-        <a:srgbClr val="1F7A8C"/>
+        <a:srgbClr val="1F5FA8"/>
       </a:hlink>
       <a:folHlink>
-        <a:srgbClr val="6C7A89"/>
+        <a:srgbClr val="6B7A90"/>
       </a:folHlink>
     </a:clrScheme>
-    <a:fontScheme name="Risques">
+    <a:fontScheme name="LMT Inde">
       <a:majorFont>
         <a:latin typeface="Cambria"/>
         <a:ea typeface=""/>

</xml_diff>